<commit_message>
Publish Kubernetes Scheduler post with English translation
Remove draft flag, add index.en.md, and refine the post based on
review feedback: restructure 1.1 around scheduler naming, fix the
in-flight event requeue behavior in 1.2.1 against the 1.32 source,
split PreScore/Score, and rewrite the Binding Cycle intro causally.

Co-Authored-By: Claude Fable 5 <noreply@anthropic.com>
</commit_message>
<xml_diff>
--- a/content/docs/theory-analysis/kubernetes-scheduler/images/images.pptx
+++ b/content/docs/theory-analysis/kubernetes-scheduler/images/images.pptx
@@ -222,7 +222,7 @@
           <a:p>
             <a:fld id="{6CD5550B-26C4-49A9-A5BA-636EF7BE6CE9}" type="datetimeFigureOut">
               <a:rPr lang="ko-KR" altLang="en-US" smtClean="0"/>
-              <a:t>2026. 10. 25.</a:t>
+              <a:t>2026. 10. 26.</a:t>
             </a:fld>
             <a:endParaRPr lang="ko-KR" altLang="en-US"/>
           </a:p>
@@ -668,7 +668,7 @@
           <a:p>
             <a:fld id="{FB30EDBD-1C2D-4C1E-B459-B60219FAB484}" type="datetimeFigureOut">
               <a:rPr lang="ko-KR" altLang="en-US" smtClean="0"/>
-              <a:t>2026. 10. 25.</a:t>
+              <a:t>2026. 10. 26.</a:t>
             </a:fld>
             <a:endParaRPr lang="ko-KR" altLang="en-US"/>
           </a:p>
@@ -831,7 +831,7 @@
           <a:p>
             <a:fld id="{FB30EDBD-1C2D-4C1E-B459-B60219FAB484}" type="datetimeFigureOut">
               <a:rPr lang="ko-KR" altLang="en-US" smtClean="0"/>
-              <a:t>2026. 10. 25.</a:t>
+              <a:t>2026. 10. 26.</a:t>
             </a:fld>
             <a:endParaRPr lang="ko-KR" altLang="en-US"/>
           </a:p>
@@ -1004,7 +1004,7 @@
           <a:p>
             <a:fld id="{FB30EDBD-1C2D-4C1E-B459-B60219FAB484}" type="datetimeFigureOut">
               <a:rPr lang="ko-KR" altLang="en-US" smtClean="0"/>
-              <a:t>2026. 10. 25.</a:t>
+              <a:t>2026. 10. 26.</a:t>
             </a:fld>
             <a:endParaRPr lang="ko-KR" altLang="en-US"/>
           </a:p>
@@ -1167,7 +1167,7 @@
           <a:p>
             <a:fld id="{FB30EDBD-1C2D-4C1E-B459-B60219FAB484}" type="datetimeFigureOut">
               <a:rPr lang="ko-KR" altLang="en-US" smtClean="0"/>
-              <a:t>2026. 10. 25.</a:t>
+              <a:t>2026. 10. 26.</a:t>
             </a:fld>
             <a:endParaRPr lang="ko-KR" altLang="en-US"/>
           </a:p>
@@ -1407,7 +1407,7 @@
           <a:p>
             <a:fld id="{FB30EDBD-1C2D-4C1E-B459-B60219FAB484}" type="datetimeFigureOut">
               <a:rPr lang="ko-KR" altLang="en-US" smtClean="0"/>
-              <a:t>2026. 10. 25.</a:t>
+              <a:t>2026. 10. 26.</a:t>
             </a:fld>
             <a:endParaRPr lang="ko-KR" altLang="en-US"/>
           </a:p>
@@ -1687,7 +1687,7 @@
           <a:p>
             <a:fld id="{FB30EDBD-1C2D-4C1E-B459-B60219FAB484}" type="datetimeFigureOut">
               <a:rPr lang="ko-KR" altLang="en-US" smtClean="0"/>
-              <a:t>2026. 10. 25.</a:t>
+              <a:t>2026. 10. 26.</a:t>
             </a:fld>
             <a:endParaRPr lang="ko-KR" altLang="en-US"/>
           </a:p>
@@ -2101,7 +2101,7 @@
           <a:p>
             <a:fld id="{FB30EDBD-1C2D-4C1E-B459-B60219FAB484}" type="datetimeFigureOut">
               <a:rPr lang="ko-KR" altLang="en-US" smtClean="0"/>
-              <a:t>2026. 10. 25.</a:t>
+              <a:t>2026. 10. 26.</a:t>
             </a:fld>
             <a:endParaRPr lang="ko-KR" altLang="en-US"/>
           </a:p>
@@ -2213,7 +2213,7 @@
           <a:p>
             <a:fld id="{FB30EDBD-1C2D-4C1E-B459-B60219FAB484}" type="datetimeFigureOut">
               <a:rPr lang="ko-KR" altLang="en-US" smtClean="0"/>
-              <a:t>2026. 10. 25.</a:t>
+              <a:t>2026. 10. 26.</a:t>
             </a:fld>
             <a:endParaRPr lang="ko-KR" altLang="en-US"/>
           </a:p>
@@ -2303,7 +2303,7 @@
           <a:p>
             <a:fld id="{FB30EDBD-1C2D-4C1E-B459-B60219FAB484}" type="datetimeFigureOut">
               <a:rPr lang="ko-KR" altLang="en-US" smtClean="0"/>
-              <a:t>2026. 10. 25.</a:t>
+              <a:t>2026. 10. 26.</a:t>
             </a:fld>
             <a:endParaRPr lang="ko-KR" altLang="en-US"/>
           </a:p>
@@ -2573,7 +2573,7 @@
           <a:p>
             <a:fld id="{FB30EDBD-1C2D-4C1E-B459-B60219FAB484}" type="datetimeFigureOut">
               <a:rPr lang="ko-KR" altLang="en-US" smtClean="0"/>
-              <a:t>2026. 10. 25.</a:t>
+              <a:t>2026. 10. 26.</a:t>
             </a:fld>
             <a:endParaRPr lang="ko-KR" altLang="en-US"/>
           </a:p>
@@ -2820,7 +2820,7 @@
           <a:p>
             <a:fld id="{FB30EDBD-1C2D-4C1E-B459-B60219FAB484}" type="datetimeFigureOut">
               <a:rPr lang="ko-KR" altLang="en-US" smtClean="0"/>
-              <a:t>2026. 10. 25.</a:t>
+              <a:t>2026. 10. 26.</a:t>
             </a:fld>
             <a:endParaRPr lang="ko-KR" altLang="en-US"/>
           </a:p>
@@ -3026,7 +3026,7 @@
           <a:p>
             <a:fld id="{FB30EDBD-1C2D-4C1E-B459-B60219FAB484}" type="datetimeFigureOut">
               <a:rPr lang="ko-KR" altLang="en-US" smtClean="0"/>
-              <a:t>2026. 10. 25.</a:t>
+              <a:t>2026. 10. 26.</a:t>
             </a:fld>
             <a:endParaRPr lang="ko-KR" altLang="en-US"/>
           </a:p>
@@ -7421,6 +7421,54 @@
           </a:p>
         </p:txBody>
       </p:sp>
+      <p:cxnSp>
+        <p:nvCxnSpPr>
+          <p:cNvPr id="9" name="꺾인 연결선[E] 8">
+            <a:extLst>
+              <a:ext uri="{FF2B5EF4-FFF2-40B4-BE49-F238E27FC236}">
+                <a16:creationId xmlns:a16="http://schemas.microsoft.com/office/drawing/2014/main" id="{45EBA73F-DC10-0520-5C20-D610FD634874}"/>
+              </a:ext>
+            </a:extLst>
+          </p:cNvPr>
+          <p:cNvCxnSpPr>
+            <a:cxnSpLocks/>
+            <a:stCxn id="104" idx="2"/>
+            <a:endCxn id="122" idx="0"/>
+          </p:cNvCxnSpPr>
+          <p:nvPr/>
+        </p:nvCxnSpPr>
+        <p:spPr>
+          <a:xfrm rot="5400000">
+            <a:off x="6262947" y="-142368"/>
+            <a:ext cx="216343" cy="3887019"/>
+          </a:xfrm>
+          <a:prstGeom prst="bentConnector3">
+            <a:avLst>
+              <a:gd name="adj1" fmla="val 50000"/>
+            </a:avLst>
+          </a:prstGeom>
+          <a:ln w="12700">
+            <a:solidFill>
+              <a:schemeClr val="tx1"/>
+            </a:solidFill>
+            <a:tailEnd type="triangle"/>
+          </a:ln>
+        </p:spPr>
+        <p:style>
+          <a:lnRef idx="1">
+            <a:schemeClr val="accent1"/>
+          </a:lnRef>
+          <a:fillRef idx="0">
+            <a:schemeClr val="accent1"/>
+          </a:fillRef>
+          <a:effectRef idx="0">
+            <a:schemeClr val="accent1"/>
+          </a:effectRef>
+          <a:fontRef idx="minor">
+            <a:schemeClr val="tx1"/>
+          </a:fontRef>
+        </p:style>
+      </p:cxnSp>
     </p:spTree>
     <p:extLst>
       <p:ext uri="{BB962C8B-B14F-4D97-AF65-F5344CB8AC3E}">

</xml_diff>